<commit_message>
test: enrichissement tests unitaires + 2 bugfixes source
Tests : +13 nouveaux cas (38 total)
  - preprocessing : grav=1 indemne, nb_victim agrégé, minuit, 2B, year_acc
  - schema_validator : Level2 colonnes manquantes, ValidationReport API
  - predict : wrong type 422, extra field ignoré, model_version, /metrics

Bugfixes :
  - make_dataset.py : grav=1 (indemne) mappé à 0 au lieu de fuiter comme 1
  - schema_validator.py : SchemaError.get() → getattr() (pandera >= 0.14)

docs : cac_mlops_architecture.pptx MAJ (slide 2 port 8080, slide 3 workflow git)

Co-Authored-By: Claude Sonnet 4.6 <noreply@anthropic.com>
</commit_message>
<xml_diff>
--- a/cac_mlops_architecture.pptx
+++ b/cac_mlops_architecture.pptx
@@ -7,6 +7,7 @@
   <p:sldIdLst>
     <p:sldId id="256" r:id="rId7"/>
     <p:sldId id="257" r:id="rId8"/>
+    <p:sldId id="258" r:id="rId9"/>
   </p:sldIdLst>
   <p:sldSz cx="12188952" cy="6858000" type="screen4x3"/>
   <p:notesSz cx="6858000" cy="9144000"/>
@@ -6975,7 +6976,7 @@
                 </a:solidFill>
                 <a:latin typeface="Calibri"/>
               </a:rPr>
-              <a:t>Services sur localhost · MinIO (S3 local) · MLflow :5000 · Prefect :4200 · pytest · flake8</a:t>
+              <a:t>Services sur localhost · MinIO (S3 local) · MLflow :5000 · API :8080 · pytest · flake8</a:t>
             </a:r>
           </a:p>
         </p:txBody>
@@ -7029,7 +7030,7 @@
                 </a:solidFill>
                 <a:latin typeface="Calibri"/>
               </a:rPr>
-              <a:t>SCALEWAY — Kubernetes (Kapsule)</a:t>
+              <a:t>SCALEWAY ACTUEL (Phase 1+2) — Docker Compose · scw-jovial-dubinsky</a:t>
             </a:r>
           </a:p>
           <a:p>
@@ -7041,7 +7042,7 @@
                 </a:solidFill>
                 <a:latin typeface="Calibri"/>
               </a:rPr>
-              <a:t>N replicas API · Object Storage · Managed DB · Container Registry · GitHub Actions CI/CD</a:t>
+              <a:t>4 containers : PostgreSQL · MinIO · MLflow · API :8080 · GitHub Actions CI/CD</a:t>
             </a:r>
           </a:p>
         </p:txBody>
@@ -7241,6 +7242,433 @@
                 <a:latin typeface="Calibri"/>
               </a:rPr>
               <a:t>  Git (code)  ·  DVC (données)  ·  MLflow (modèles)  ·  Pandera (validation)  ·  Prefect (orchestration)  ·  NGINX (sécurité)  ·  Evidently (drift)  ·  Prometheus/Grafana (monitoring)</a:t>
+            </a:r>
+          </a:p>
+        </p:txBody>
+      </p:sp>
+    </p:spTree>
+  </p:cSld>
+  <p:clrMapOvr>
+    <a:masterClrMapping/>
+  </p:clrMapOvr>
+</p:sld>
+</file>
+
+<file path=ppt/slides/slide3.xml><?xml version="1.0" encoding="utf-8"?>
+<p:sld xmlns:a="http://schemas.openxmlformats.org/drawingml/2006/main" xmlns:p="http://schemas.openxmlformats.org/presentationml/2006/main" xmlns:r="http://schemas.openxmlformats.org/officeDocument/2006/relationships">
+  <p:cSld>
+    <p:bg>
+      <p:bgPr>
+        <a:solidFill>
+          <a:srgbClr val="1F3564"/>
+        </a:solidFill>
+        <a:effectLst/>
+      </p:bgPr>
+    </p:bg>
+    <p:spTree>
+      <p:nvGrpSpPr>
+        <p:cNvPr id="1" name=""/>
+        <p:cNvGrpSpPr/>
+        <p:nvPr/>
+      </p:nvGrpSpPr>
+      <p:grpSpPr/>
+      <p:sp>
+        <p:nvSpPr>
+          <p:cNvPr id="2" name="TextBox 1"/>
+          <p:cNvSpPr txBox="1"/>
+          <p:nvPr/>
+        </p:nvSpPr>
+        <p:spPr>
+          <a:xfrm>
+            <a:off x="365760" y="182880"/>
+            <a:ext cx="10972800" cy="640080"/>
+          </a:xfrm>
+          <a:prstGeom prst="rect">
+            <a:avLst/>
+          </a:prstGeom>
+          <a:noFill/>
+        </p:spPr>
+        <p:txBody>
+          <a:bodyPr wrap="square">
+            <a:spAutoFit/>
+          </a:bodyPr>
+          <a:lstStyle/>
+          <a:p>
+            <a:pPr algn="ctr"/>
+            <a:r>
+              <a:rPr sz="2800" b="1">
+                <a:solidFill>
+                  <a:srgbClr val="FFFFFF"/>
+                </a:solidFill>
+              </a:rPr>
+              <a:t>Workflow Collaboratif — Git · CI · CD</a:t>
+            </a:r>
+          </a:p>
+        </p:txBody>
+      </p:sp>
+      <p:sp>
+        <p:nvSpPr>
+          <p:cNvPr id="3" name="TextBox 2"/>
+          <p:cNvSpPr txBox="1"/>
+          <p:nvPr/>
+        </p:nvSpPr>
+        <p:spPr>
+          <a:xfrm>
+            <a:off x="365760" y="822960"/>
+            <a:ext cx="10972800" cy="365760"/>
+          </a:xfrm>
+          <a:prstGeom prst="rect">
+            <a:avLst/>
+          </a:prstGeom>
+          <a:noFill/>
+        </p:spPr>
+        <p:txBody>
+          <a:bodyPr wrap="square">
+            <a:spAutoFit/>
+          </a:bodyPr>
+          <a:lstStyle/>
+          <a:p>
+            <a:pPr algn="ctr"/>
+            <a:r>
+              <a:rPr sz="1400" b="0">
+                <a:solidFill>
+                  <a:srgbClr val="FF6B00"/>
+                </a:solidFill>
+              </a:rPr>
+              <a:t>jacques / noel  →  PR  →  main  →  deploy automatique Scaleway</a:t>
+            </a:r>
+          </a:p>
+        </p:txBody>
+      </p:sp>
+      <p:sp>
+        <p:nvSpPr>
+          <p:cNvPr id="4" name="TextBox 3"/>
+          <p:cNvSpPr txBox="1"/>
+          <p:nvPr/>
+        </p:nvSpPr>
+        <p:spPr>
+          <a:xfrm>
+            <a:off x="365760" y="1371600"/>
+            <a:ext cx="2926080" cy="411480"/>
+          </a:xfrm>
+          <a:prstGeom prst="rect">
+            <a:avLst/>
+          </a:prstGeom>
+          <a:solidFill>
+            <a:srgbClr val="0070C0"/>
+          </a:solidFill>
+        </p:spPr>
+        <p:txBody>
+          <a:bodyPr wrap="square">
+            <a:spAutoFit/>
+          </a:bodyPr>
+          <a:lstStyle/>
+          <a:p>
+            <a:pPr algn="ctr"/>
+            <a:r>
+              <a:rPr sz="1300" b="1">
+                <a:solidFill>
+                  <a:srgbClr val="FFFFFF"/>
+                </a:solidFill>
+              </a:rPr>
+              <a:t>BRANCHES</a:t>
+            </a:r>
+          </a:p>
+        </p:txBody>
+      </p:sp>
+      <p:sp>
+        <p:nvSpPr>
+          <p:cNvPr id="5" name="TextBox 4"/>
+          <p:cNvSpPr txBox="1"/>
+          <p:nvPr/>
+        </p:nvSpPr>
+        <p:spPr>
+          <a:xfrm>
+            <a:off x="365760" y="1828800"/>
+            <a:ext cx="2926080" cy="1097280"/>
+          </a:xfrm>
+          <a:prstGeom prst="rect">
+            <a:avLst/>
+          </a:prstGeom>
+          <a:noFill/>
+        </p:spPr>
+        <p:txBody>
+          <a:bodyPr wrap="square">
+            <a:spAutoFit/>
+          </a:bodyPr>
+          <a:lstStyle/>
+          <a:p>
+            <a:pPr algn="l"/>
+            <a:r>
+              <a:rPr sz="1200" b="0">
+                <a:solidFill>
+                  <a:srgbClr val="FFFFFF"/>
+                </a:solidFill>
+              </a:rPr>
+              <a:t>jacques  →  commits libres de Jacques
+noel       →  commits libres de Noël
+main       →  pas de commit direct
+               uniquement via Pull Request</a:t>
+            </a:r>
+          </a:p>
+        </p:txBody>
+      </p:sp>
+      <p:sp>
+        <p:nvSpPr>
+          <p:cNvPr id="6" name="TextBox 5"/>
+          <p:cNvSpPr txBox="1"/>
+          <p:nvPr/>
+        </p:nvSpPr>
+        <p:spPr>
+          <a:xfrm>
+            <a:off x="3566160" y="1371600"/>
+            <a:ext cx="3291840" cy="411480"/>
+          </a:xfrm>
+          <a:prstGeom prst="rect">
+            <a:avLst/>
+          </a:prstGeom>
+          <a:solidFill>
+            <a:srgbClr val="0070C0"/>
+          </a:solidFill>
+        </p:spPr>
+        <p:txBody>
+          <a:bodyPr wrap="square">
+            <a:spAutoFit/>
+          </a:bodyPr>
+          <a:lstStyle/>
+          <a:p>
+            <a:pPr algn="ctr"/>
+            <a:r>
+              <a:rPr sz="1300" b="1">
+                <a:solidFill>
+                  <a:srgbClr val="FFFFFF"/>
+                </a:solidFill>
+              </a:rPr>
+              <a:t>ci.yml  —  lint + tests</a:t>
+            </a:r>
+          </a:p>
+        </p:txBody>
+      </p:sp>
+      <p:sp>
+        <p:nvSpPr>
+          <p:cNvPr id="7" name="TextBox 6"/>
+          <p:cNvSpPr txBox="1"/>
+          <p:nvPr/>
+        </p:nvSpPr>
+        <p:spPr>
+          <a:xfrm>
+            <a:off x="3566160" y="1828800"/>
+            <a:ext cx="3291840" cy="2011680"/>
+          </a:xfrm>
+          <a:prstGeom prst="rect">
+            <a:avLst/>
+          </a:prstGeom>
+          <a:noFill/>
+        </p:spPr>
+        <p:txBody>
+          <a:bodyPr wrap="square">
+            <a:spAutoFit/>
+          </a:bodyPr>
+          <a:lstStyle/>
+          <a:p>
+            <a:pPr algn="l"/>
+            <a:r>
+              <a:rPr sz="1100" b="0">
+                <a:solidFill>
+                  <a:srgbClr val="FFFFFF"/>
+                </a:solidFill>
+              </a:rPr>
+              <a:t>Déclenché sur : push jacques/noel
+                          PR vers main
+1. pip install requirements
+2. flake8  (erreurs bloquantes)
+3. pytest tests/unit/
+✗ échoue  →  PR bloquée
+✓ passe   →  merge autorisé</a:t>
+            </a:r>
+          </a:p>
+        </p:txBody>
+      </p:sp>
+      <p:sp>
+        <p:nvSpPr>
+          <p:cNvPr id="8" name="TextBox 7"/>
+          <p:cNvSpPr txBox="1"/>
+          <p:nvPr/>
+        </p:nvSpPr>
+        <p:spPr>
+          <a:xfrm>
+            <a:off x="7132320" y="1371600"/>
+            <a:ext cx="4023360" cy="411480"/>
+          </a:xfrm>
+          <a:prstGeom prst="rect">
+            <a:avLst/>
+          </a:prstGeom>
+          <a:solidFill>
+            <a:srgbClr val="00874A"/>
+          </a:solidFill>
+        </p:spPr>
+        <p:txBody>
+          <a:bodyPr wrap="square">
+            <a:spAutoFit/>
+          </a:bodyPr>
+          <a:lstStyle/>
+          <a:p>
+            <a:pPr algn="ctr"/>
+            <a:r>
+              <a:rPr sz="1300" b="1">
+                <a:solidFill>
+                  <a:srgbClr val="FFFFFF"/>
+                </a:solidFill>
+              </a:rPr>
+              <a:t>deploy.yml  —  SSH deploy</a:t>
+            </a:r>
+          </a:p>
+        </p:txBody>
+      </p:sp>
+      <p:sp>
+        <p:nvSpPr>
+          <p:cNvPr id="9" name="TextBox 8"/>
+          <p:cNvSpPr txBox="1"/>
+          <p:nvPr/>
+        </p:nvSpPr>
+        <p:spPr>
+          <a:xfrm>
+            <a:off x="7132320" y="1828800"/>
+            <a:ext cx="4023360" cy="2011680"/>
+          </a:xfrm>
+          <a:prstGeom prst="rect">
+            <a:avLst/>
+          </a:prstGeom>
+          <a:noFill/>
+        </p:spPr>
+        <p:txBody>
+          <a:bodyPr wrap="square">
+            <a:spAutoFit/>
+          </a:bodyPr>
+          <a:lstStyle/>
+          <a:p>
+            <a:pPr algn="l"/>
+            <a:r>
+              <a:rPr sz="1100" b="0">
+                <a:solidFill>
+                  <a:srgbClr val="FFFFFF"/>
+                </a:solidFill>
+              </a:rPr>
+              <a:t>Déclenché sur : merge dans main
+1. SSH → deploy@51.159.187.132
+2. git reset --hard origin/main
+3. dvc pull  (données Scaleway S3)
+4. docker compose down &amp;&amp; up --build
+5. curl :8080/health  (retry 90s max)
+✗ timeout  →  logs API + exit 1
+✓ API OK  →  deploy terminé</a:t>
+            </a:r>
+          </a:p>
+        </p:txBody>
+      </p:sp>
+      <p:sp>
+        <p:nvSpPr>
+          <p:cNvPr id="10" name="TextBox 9"/>
+          <p:cNvSpPr txBox="1"/>
+          <p:nvPr/>
+        </p:nvSpPr>
+        <p:spPr>
+          <a:xfrm>
+            <a:off x="365760" y="3977639"/>
+            <a:ext cx="10789920" cy="365760"/>
+          </a:xfrm>
+          <a:prstGeom prst="rect">
+            <a:avLst/>
+          </a:prstGeom>
+          <a:solidFill>
+            <a:srgbClr val="FF6B00"/>
+          </a:solidFill>
+        </p:spPr>
+        <p:txBody>
+          <a:bodyPr wrap="square">
+            <a:spAutoFit/>
+          </a:bodyPr>
+          <a:lstStyle/>
+          <a:p>
+            <a:pPr algn="ctr"/>
+            <a:r>
+              <a:rPr sz="1300" b="1">
+                <a:solidFill>
+                  <a:srgbClr val="FFFFFF"/>
+                </a:solidFill>
+              </a:rPr>
+              <a:t>WORKFLOW QUOTIDIEN</a:t>
+            </a:r>
+          </a:p>
+        </p:txBody>
+      </p:sp>
+      <p:sp>
+        <p:nvSpPr>
+          <p:cNvPr id="11" name="TextBox 10"/>
+          <p:cNvSpPr txBox="1"/>
+          <p:nvPr/>
+        </p:nvSpPr>
+        <p:spPr>
+          <a:xfrm>
+            <a:off x="365760" y="4389120"/>
+            <a:ext cx="10789920" cy="1280160"/>
+          </a:xfrm>
+          <a:prstGeom prst="rect">
+            <a:avLst/>
+          </a:prstGeom>
+          <a:noFill/>
+        </p:spPr>
+        <p:txBody>
+          <a:bodyPr wrap="square">
+            <a:spAutoFit/>
+          </a:bodyPr>
+          <a:lstStyle/>
+          <a:p>
+            <a:pPr algn="l"/>
+            <a:r>
+              <a:rPr sz="1100" b="0">
+                <a:solidFill>
+                  <a:srgbClr val="FFFFFF"/>
+                </a:solidFill>
+              </a:rPr>
+              <a:t>git fetch origin &amp;&amp; git merge origin/main     # récupère les modifs du collègue
+git add src/...  &amp;&amp;  git commit -m 'feat: ...'     # travail sur ta branche
+dvc push                                                    # pousse les données → Scaleway Object Storage
+git push origin jacques                                 # puis ouvrir une PR sur GitHub  →  merge  →  deploy auto</a:t>
+            </a:r>
+          </a:p>
+        </p:txBody>
+      </p:sp>
+      <p:sp>
+        <p:nvSpPr>
+          <p:cNvPr id="12" name="TextBox 11"/>
+          <p:cNvSpPr txBox="1"/>
+          <p:nvPr/>
+        </p:nvSpPr>
+        <p:spPr>
+          <a:xfrm>
+            <a:off x="365760" y="5806440"/>
+            <a:ext cx="10789920" cy="320040"/>
+          </a:xfrm>
+          <a:prstGeom prst="rect">
+            <a:avLst/>
+          </a:prstGeom>
+          <a:noFill/>
+        </p:spPr>
+        <p:txBody>
+          <a:bodyPr wrap="square">
+            <a:spAutoFit/>
+          </a:bodyPr>
+          <a:lstStyle/>
+          <a:p>
+            <a:pPr algn="ctr"/>
+            <a:r>
+              <a:rPr sz="1000" b="0">
+                <a:solidFill>
+                  <a:srgbClr val="FF6B00"/>
+                </a:solidFill>
+              </a:rPr>
+              <a:t>Liora — MLOps Accidents</a:t>
             </a:r>
           </a:p>
         </p:txBody>

</xml_diff>

<commit_message>
docs: reflect Phase 1 done + Phase 2 in progress in all doc files
- architecture.md: port 5000→5001, Phase 1 marked ✅ with actual deliverables,
  Phase 2 section shows done (2021 run) vs todo (2022+2023), Scaleway section
  split into current state (docker-compose DEV1-L) vs target (K8s Phase 3+),
  MLflow v3.1.0 and aliases noted throughout
- execsum.md: MODÈLE EN PRODUCTION block with 2021 KPI, tests 38/38,
  PHASE 2 marked EN COURS
- cac_mlops_architecture.pptx: slide 2 MLflow :5001, Scaleway section adds
  v3.1.0 and KPI results (accuracy=0.777 f1=0.648 auc=0.838 recall=0.593)

Co-Authored-By: Claude Sonnet 4.6 <noreply@anthropic.com>
</commit_message>
<xml_diff>
--- a/cac_mlops_architecture.pptx
+++ b/cac_mlops_architecture.pptx
@@ -6976,7 +6976,7 @@
                 </a:solidFill>
                 <a:latin typeface="Calibri"/>
               </a:rPr>
-              <a:t>Services sur localhost · MinIO (S3 local) · MLflow :5000 · API :8080 · pytest · flake8</a:t>
+              <a:t>Services sur localhost · MinIO (S3 local) · MLflow :5001 · API :8080 · pytest · flake8</a:t>
             </a:r>
           </a:p>
         </p:txBody>
@@ -7042,7 +7042,8 @@
                 </a:solidFill>
                 <a:latin typeface="Calibri"/>
               </a:rPr>
-              <a:t>4 containers : PostgreSQL · MinIO · MLflow · API :8080 · GitHub Actions CI/CD</a:t>
+              <a:t>4 containers : PostgreSQL · MinIO · MLflow v3.1.0 · API :8080 · GitHub Actions CI/CD
+Modèle @Production : accuracy=0.777 · f1=0.648 · auc=0.838 · recall=0.593</a:t>
             </a:r>
           </a:p>
         </p:txBody>

</xml_diff>